<commit_message>
Concept 2 brand assets: templates, graphics, guidelines, docs and scripts refreshed
</commit_message>
<xml_diff>
--- a/deliverables/fieldwork-launch-kit/04-corporate-sales/fieldwork-sales-deck.pptx
+++ b/deliverables/fieldwork-launch-kit/04-corporate-sales/fieldwork-sales-deck.pptx
@@ -2014,7 +2014,7 @@
     <p:bg>
       <p:bgPr>
         <a:solidFill>
-          <a:srgbClr val="25306E"/>
+          <a:srgbClr val="2340FF"/>
         </a:solidFill>
       </p:bgPr>
     </p:bg>
@@ -2059,7 +2059,7 @@
             <a:r>
               <a:rPr lang="en-US" sz="1000" spc="200" kern="0" dirty="0">
                 <a:solidFill>
-                  <a:srgbClr val="E3A98C"/>
+                  <a:srgbClr val="F3F2ED"/>
                 </a:solidFill>
                 <a:latin typeface="Courier New" pitchFamily="34" charset="0"/>
                 <a:ea typeface="Courier New" pitchFamily="34" charset="-122"/>
@@ -2098,7 +2098,7 @@
             <a:r>
               <a:rPr lang="en-US" sz="8000" b="1" dirty="0">
                 <a:solidFill>
-                  <a:srgbClr val="F1EFEA"/>
+                  <a:srgbClr val="F3F2ED"/>
                 </a:solidFill>
                 <a:latin typeface="Arial" pitchFamily="34" charset="0"/>
                 <a:ea typeface="Arial" pitchFamily="34" charset="-122"/>
@@ -2135,13 +2135,13 @@
               <a:buNone/>
             </a:pPr>
             <a:r>
-              <a:rPr lang="en-US" sz="2200" i="1" dirty="0">
-                <a:solidFill>
-                  <a:srgbClr val="F1EFEA"/>
-                </a:solidFill>
-                <a:latin typeface="Georgia" pitchFamily="34" charset="0"/>
-                <a:ea typeface="Georgia" pitchFamily="34" charset="-122"/>
-                <a:cs typeface="Georgia" pitchFamily="34" charset="-120"/>
+              <a:rPr lang="en-US" sz="2200" dirty="0">
+                <a:solidFill>
+                  <a:srgbClr val="F3F2ED"/>
+                </a:solidFill>
+                <a:latin typeface="Arial" pitchFamily="34" charset="0"/>
+                <a:ea typeface="Arial" pitchFamily="34" charset="-122"/>
+                <a:cs typeface="Arial" pitchFamily="34" charset="-120"/>
               </a:rPr>
               <a:t>Practical AI training for estate and letting teams</a:t>
             </a:r>
@@ -2176,7 +2176,7 @@
             <a:r>
               <a:rPr lang="en-US" sz="1000" dirty="0">
                 <a:solidFill>
-                  <a:srgbClr val="F1EFEA"/>
+                  <a:srgbClr val="F3F2ED"/>
                 </a:solidFill>
                 <a:latin typeface="Courier New" pitchFamily="34" charset="0"/>
                 <a:ea typeface="Courier New" pitchFamily="34" charset="-122"/>
@@ -2215,11 +2215,11 @@
             <a:r>
               <a:rPr lang="en-US" sz="1100" dirty="0">
                 <a:solidFill>
-                  <a:srgbClr val="E3A98C"/>
-                </a:solidFill>
-                <a:latin typeface="Georgia" pitchFamily="34" charset="0"/>
-                <a:ea typeface="Georgia" pitchFamily="34" charset="-122"/>
-                <a:cs typeface="Georgia" pitchFamily="34" charset="-120"/>
+                  <a:srgbClr val="F3F2ED"/>
+                </a:solidFill>
+                <a:latin typeface="Arial" pitchFamily="34" charset="0"/>
+                <a:ea typeface="Arial" pitchFamily="34" charset="-122"/>
+                <a:cs typeface="Arial" pitchFamily="34" charset="-120"/>
               </a:rPr>
               <a:t>Fieldwork</a:t>
             </a:r>
@@ -2241,7 +2241,7 @@
     <p:bg>
       <p:bgPr>
         <a:solidFill>
-          <a:srgbClr val="F1EFEA"/>
+          <a:srgbClr val="F3F2ED"/>
         </a:solidFill>
       </p:bgPr>
     </p:bg>
@@ -2286,7 +2286,7 @@
             <a:r>
               <a:rPr lang="en-US" sz="1000" spc="200" kern="0" dirty="0">
                 <a:solidFill>
-                  <a:srgbClr val="A8512F"/>
+                  <a:srgbClr val="2340FF"/>
                 </a:solidFill>
                 <a:latin typeface="Courier New" pitchFamily="34" charset="0"/>
                 <a:ea typeface="Courier New" pitchFamily="34" charset="-122"/>
@@ -2325,7 +2325,7 @@
             <a:r>
               <a:rPr lang="en-US" sz="4400" b="1" dirty="0">
                 <a:solidFill>
-                  <a:srgbClr val="262422"/>
+                  <a:srgbClr val="121212"/>
                 </a:solidFill>
                 <a:latin typeface="Arial" pitchFamily="34" charset="0"/>
                 <a:ea typeface="Arial" pitchFamily="34" charset="-122"/>
@@ -2368,7 +2368,7 @@
             <a:r>
               <a:rPr lang="en-US" sz="2400" dirty="0">
                 <a:solidFill>
-                  <a:srgbClr val="262422"/>
+                  <a:srgbClr val="121212"/>
                 </a:solidFill>
                 <a:latin typeface="Arial" pitchFamily="34" charset="0"/>
                 <a:ea typeface="Arial" pitchFamily="34" charset="-122"/>
@@ -2389,7 +2389,7 @@
             <a:r>
               <a:rPr lang="en-US" sz="2400" dirty="0">
                 <a:solidFill>
-                  <a:srgbClr val="262422"/>
+                  <a:srgbClr val="121212"/>
                 </a:solidFill>
                 <a:latin typeface="Arial" pitchFamily="34" charset="0"/>
                 <a:ea typeface="Arial" pitchFamily="34" charset="-122"/>
@@ -2410,7 +2410,7 @@
             <a:r>
               <a:rPr lang="en-US" sz="2400" dirty="0">
                 <a:solidFill>
-                  <a:srgbClr val="262422"/>
+                  <a:srgbClr val="121212"/>
                 </a:solidFill>
                 <a:latin typeface="Arial" pitchFamily="34" charset="0"/>
                 <a:ea typeface="Arial" pitchFamily="34" charset="-122"/>
@@ -2431,7 +2431,7 @@
             <a:r>
               <a:rPr lang="en-US" sz="2400" dirty="0">
                 <a:solidFill>
-                  <a:srgbClr val="262422"/>
+                  <a:srgbClr val="121212"/>
                 </a:solidFill>
                 <a:latin typeface="Arial" pitchFamily="34" charset="0"/>
                 <a:ea typeface="Arial" pitchFamily="34" charset="-122"/>
@@ -2470,11 +2470,11 @@
             <a:r>
               <a:rPr lang="en-US" sz="1100" dirty="0">
                 <a:solidFill>
-                  <a:srgbClr val="A8512F"/>
-                </a:solidFill>
-                <a:latin typeface="Georgia" pitchFamily="34" charset="0"/>
-                <a:ea typeface="Georgia" pitchFamily="34" charset="-122"/>
-                <a:cs typeface="Georgia" pitchFamily="34" charset="-120"/>
+                  <a:srgbClr val="2340FF"/>
+                </a:solidFill>
+                <a:latin typeface="Arial" pitchFamily="34" charset="0"/>
+                <a:ea typeface="Arial" pitchFamily="34" charset="-122"/>
+                <a:cs typeface="Arial" pitchFamily="34" charset="-120"/>
               </a:rPr>
               <a:t>Fieldwork</a:t>
             </a:r>
@@ -2496,7 +2496,7 @@
     <p:bg>
       <p:bgPr>
         <a:solidFill>
-          <a:srgbClr val="F1EFEA"/>
+          <a:srgbClr val="F3F2ED"/>
         </a:solidFill>
       </p:bgPr>
     </p:bg>
@@ -2541,7 +2541,7 @@
             <a:r>
               <a:rPr lang="en-US" sz="1000" spc="200" kern="0" dirty="0">
                 <a:solidFill>
-                  <a:srgbClr val="A8512F"/>
+                  <a:srgbClr val="2340FF"/>
                 </a:solidFill>
                 <a:latin typeface="Courier New" pitchFamily="34" charset="0"/>
                 <a:ea typeface="Courier New" pitchFamily="34" charset="-122"/>
@@ -2580,7 +2580,7 @@
             <a:r>
               <a:rPr lang="en-US" sz="4400" b="1" dirty="0">
                 <a:solidFill>
-                  <a:srgbClr val="262422"/>
+                  <a:srgbClr val="121212"/>
                 </a:solidFill>
                 <a:latin typeface="Arial" pitchFamily="34" charset="0"/>
                 <a:ea typeface="Arial" pitchFamily="34" charset="-122"/>
@@ -2623,7 +2623,7 @@
             <a:r>
               <a:rPr lang="en-US" sz="2400" dirty="0">
                 <a:solidFill>
-                  <a:srgbClr val="262422"/>
+                  <a:srgbClr val="121212"/>
                 </a:solidFill>
                 <a:latin typeface="Arial" pitchFamily="34" charset="0"/>
                 <a:ea typeface="Arial" pitchFamily="34" charset="-122"/>
@@ -2644,7 +2644,7 @@
             <a:r>
               <a:rPr lang="en-US" sz="2400" dirty="0">
                 <a:solidFill>
-                  <a:srgbClr val="262422"/>
+                  <a:srgbClr val="121212"/>
                 </a:solidFill>
                 <a:latin typeface="Arial" pitchFamily="34" charset="0"/>
                 <a:ea typeface="Arial" pitchFamily="34" charset="-122"/>
@@ -2665,7 +2665,7 @@
             <a:r>
               <a:rPr lang="en-US" sz="2400" dirty="0">
                 <a:solidFill>
-                  <a:srgbClr val="262422"/>
+                  <a:srgbClr val="121212"/>
                 </a:solidFill>
                 <a:latin typeface="Arial" pitchFamily="34" charset="0"/>
                 <a:ea typeface="Arial" pitchFamily="34" charset="-122"/>
@@ -2686,7 +2686,7 @@
             <a:r>
               <a:rPr lang="en-US" sz="2400" dirty="0">
                 <a:solidFill>
-                  <a:srgbClr val="262422"/>
+                  <a:srgbClr val="121212"/>
                 </a:solidFill>
                 <a:latin typeface="Arial" pitchFamily="34" charset="0"/>
                 <a:ea typeface="Arial" pitchFamily="34" charset="-122"/>
@@ -2707,7 +2707,7 @@
             <a:r>
               <a:rPr lang="en-US" sz="2400" dirty="0">
                 <a:solidFill>
-                  <a:srgbClr val="262422"/>
+                  <a:srgbClr val="121212"/>
                 </a:solidFill>
                 <a:latin typeface="Arial" pitchFamily="34" charset="0"/>
                 <a:ea typeface="Arial" pitchFamily="34" charset="-122"/>
@@ -2746,11 +2746,11 @@
             <a:r>
               <a:rPr lang="en-US" sz="1100" dirty="0">
                 <a:solidFill>
-                  <a:srgbClr val="A8512F"/>
-                </a:solidFill>
-                <a:latin typeface="Georgia" pitchFamily="34" charset="0"/>
-                <a:ea typeface="Georgia" pitchFamily="34" charset="-122"/>
-                <a:cs typeface="Georgia" pitchFamily="34" charset="-120"/>
+                  <a:srgbClr val="2340FF"/>
+                </a:solidFill>
+                <a:latin typeface="Arial" pitchFamily="34" charset="0"/>
+                <a:ea typeface="Arial" pitchFamily="34" charset="-122"/>
+                <a:cs typeface="Arial" pitchFamily="34" charset="-120"/>
               </a:rPr>
               <a:t>Fieldwork</a:t>
             </a:r>
@@ -2772,7 +2772,7 @@
     <p:bg>
       <p:bgPr>
         <a:solidFill>
-          <a:srgbClr val="262422"/>
+          <a:srgbClr val="121212"/>
         </a:solidFill>
       </p:bgPr>
     </p:bg>
@@ -2817,7 +2817,7 @@
             <a:r>
               <a:rPr lang="en-US" sz="1000" spc="200" kern="0" dirty="0">
                 <a:solidFill>
-                  <a:srgbClr val="E3A98C"/>
+                  <a:srgbClr val="7C8FFF"/>
                 </a:solidFill>
                 <a:latin typeface="Courier New" pitchFamily="34" charset="0"/>
                 <a:ea typeface="Courier New" pitchFamily="34" charset="-122"/>
@@ -2856,7 +2856,7 @@
             <a:r>
               <a:rPr lang="en-US" sz="4400" b="1" dirty="0">
                 <a:solidFill>
-                  <a:srgbClr val="F1EFEA"/>
+                  <a:srgbClr val="F3F2ED"/>
                 </a:solidFill>
                 <a:latin typeface="Arial" pitchFamily="34" charset="0"/>
                 <a:ea typeface="Arial" pitchFamily="34" charset="-122"/>
@@ -2899,7 +2899,7 @@
             <a:r>
               <a:rPr lang="en-US" sz="2400" dirty="0">
                 <a:solidFill>
-                  <a:srgbClr val="F1EFEA"/>
+                  <a:srgbClr val="F3F2ED"/>
                 </a:solidFill>
                 <a:latin typeface="Arial" pitchFamily="34" charset="0"/>
                 <a:ea typeface="Arial" pitchFamily="34" charset="-122"/>
@@ -2920,7 +2920,7 @@
             <a:r>
               <a:rPr lang="en-US" sz="2400" dirty="0">
                 <a:solidFill>
-                  <a:srgbClr val="F1EFEA"/>
+                  <a:srgbClr val="F3F2ED"/>
                 </a:solidFill>
                 <a:latin typeface="Arial" pitchFamily="34" charset="0"/>
                 <a:ea typeface="Arial" pitchFamily="34" charset="-122"/>
@@ -2941,7 +2941,7 @@
             <a:r>
               <a:rPr lang="en-US" sz="2400" dirty="0">
                 <a:solidFill>
-                  <a:srgbClr val="F1EFEA"/>
+                  <a:srgbClr val="F3F2ED"/>
                 </a:solidFill>
                 <a:latin typeface="Arial" pitchFamily="34" charset="0"/>
                 <a:ea typeface="Arial" pitchFamily="34" charset="-122"/>
@@ -2962,7 +2962,7 @@
             <a:r>
               <a:rPr lang="en-US" sz="2400" dirty="0">
                 <a:solidFill>
-                  <a:srgbClr val="F1EFEA"/>
+                  <a:srgbClr val="F3F2ED"/>
                 </a:solidFill>
                 <a:latin typeface="Arial" pitchFamily="34" charset="0"/>
                 <a:ea typeface="Arial" pitchFamily="34" charset="-122"/>
@@ -3001,11 +3001,11 @@
             <a:r>
               <a:rPr lang="en-US" sz="1100" dirty="0">
                 <a:solidFill>
-                  <a:srgbClr val="E3A98C"/>
-                </a:solidFill>
-                <a:latin typeface="Georgia" pitchFamily="34" charset="0"/>
-                <a:ea typeface="Georgia" pitchFamily="34" charset="-122"/>
-                <a:cs typeface="Georgia" pitchFamily="34" charset="-120"/>
+                  <a:srgbClr val="7C8FFF"/>
+                </a:solidFill>
+                <a:latin typeface="Arial" pitchFamily="34" charset="0"/>
+                <a:ea typeface="Arial" pitchFamily="34" charset="-122"/>
+                <a:cs typeface="Arial" pitchFamily="34" charset="-120"/>
               </a:rPr>
               <a:t>Fieldwork</a:t>
             </a:r>
@@ -3027,7 +3027,7 @@
     <p:bg>
       <p:bgPr>
         <a:solidFill>
-          <a:srgbClr val="F1EFEA"/>
+          <a:srgbClr val="F3F2ED"/>
         </a:solidFill>
       </p:bgPr>
     </p:bg>
@@ -3072,7 +3072,7 @@
             <a:r>
               <a:rPr lang="en-US" sz="1000" spc="200" kern="0" dirty="0">
                 <a:solidFill>
-                  <a:srgbClr val="A8512F"/>
+                  <a:srgbClr val="2340FF"/>
                 </a:solidFill>
                 <a:latin typeface="Courier New" pitchFamily="34" charset="0"/>
                 <a:ea typeface="Courier New" pitchFamily="34" charset="-122"/>
@@ -3111,7 +3111,7 @@
             <a:r>
               <a:rPr lang="en-US" sz="4400" b="1" dirty="0">
                 <a:solidFill>
-                  <a:srgbClr val="262422"/>
+                  <a:srgbClr val="121212"/>
                 </a:solidFill>
                 <a:latin typeface="Arial" pitchFamily="34" charset="0"/>
                 <a:ea typeface="Arial" pitchFamily="34" charset="-122"/>
@@ -3154,7 +3154,7 @@
             <a:r>
               <a:rPr lang="en-US" sz="2400" dirty="0">
                 <a:solidFill>
-                  <a:srgbClr val="262422"/>
+                  <a:srgbClr val="121212"/>
                 </a:solidFill>
                 <a:latin typeface="Arial" pitchFamily="34" charset="0"/>
                 <a:ea typeface="Arial" pitchFamily="34" charset="-122"/>
@@ -3175,7 +3175,7 @@
             <a:r>
               <a:rPr lang="en-US" sz="2400" dirty="0">
                 <a:solidFill>
-                  <a:srgbClr val="262422"/>
+                  <a:srgbClr val="121212"/>
                 </a:solidFill>
                 <a:latin typeface="Arial" pitchFamily="34" charset="0"/>
                 <a:ea typeface="Arial" pitchFamily="34" charset="-122"/>
@@ -3196,7 +3196,7 @@
             <a:r>
               <a:rPr lang="en-US" sz="2400" dirty="0">
                 <a:solidFill>
-                  <a:srgbClr val="262422"/>
+                  <a:srgbClr val="121212"/>
                 </a:solidFill>
                 <a:latin typeface="Arial" pitchFamily="34" charset="0"/>
                 <a:ea typeface="Arial" pitchFamily="34" charset="-122"/>
@@ -3217,7 +3217,7 @@
             <a:r>
               <a:rPr lang="en-US" sz="2400" dirty="0">
                 <a:solidFill>
-                  <a:srgbClr val="262422"/>
+                  <a:srgbClr val="121212"/>
                 </a:solidFill>
                 <a:latin typeface="Arial" pitchFamily="34" charset="0"/>
                 <a:ea typeface="Arial" pitchFamily="34" charset="-122"/>
@@ -3238,7 +3238,7 @@
             <a:r>
               <a:rPr lang="en-US" sz="2400" dirty="0">
                 <a:solidFill>
-                  <a:srgbClr val="262422"/>
+                  <a:srgbClr val="121212"/>
                 </a:solidFill>
                 <a:latin typeface="Arial" pitchFamily="34" charset="0"/>
                 <a:ea typeface="Arial" pitchFamily="34" charset="-122"/>
@@ -3259,7 +3259,7 @@
             <a:r>
               <a:rPr lang="en-US" sz="2400" dirty="0">
                 <a:solidFill>
-                  <a:srgbClr val="262422"/>
+                  <a:srgbClr val="121212"/>
                 </a:solidFill>
                 <a:latin typeface="Arial" pitchFamily="34" charset="0"/>
                 <a:ea typeface="Arial" pitchFamily="34" charset="-122"/>
@@ -3298,11 +3298,11 @@
             <a:r>
               <a:rPr lang="en-US" sz="1100" dirty="0">
                 <a:solidFill>
-                  <a:srgbClr val="A8512F"/>
-                </a:solidFill>
-                <a:latin typeface="Georgia" pitchFamily="34" charset="0"/>
-                <a:ea typeface="Georgia" pitchFamily="34" charset="-122"/>
-                <a:cs typeface="Georgia" pitchFamily="34" charset="-120"/>
+                  <a:srgbClr val="2340FF"/>
+                </a:solidFill>
+                <a:latin typeface="Arial" pitchFamily="34" charset="0"/>
+                <a:ea typeface="Arial" pitchFamily="34" charset="-122"/>
+                <a:cs typeface="Arial" pitchFamily="34" charset="-120"/>
               </a:rPr>
               <a:t>Fieldwork</a:t>
             </a:r>
@@ -3324,7 +3324,7 @@
     <p:bg>
       <p:bgPr>
         <a:solidFill>
-          <a:srgbClr val="25306E"/>
+          <a:srgbClr val="2340FF"/>
         </a:solidFill>
       </p:bgPr>
     </p:bg>
@@ -3369,7 +3369,7 @@
             <a:r>
               <a:rPr lang="en-US" sz="1000" spc="200" kern="0" dirty="0">
                 <a:solidFill>
-                  <a:srgbClr val="E3A98C"/>
+                  <a:srgbClr val="F3F2ED"/>
                 </a:solidFill>
                 <a:latin typeface="Courier New" pitchFamily="34" charset="0"/>
                 <a:ea typeface="Courier New" pitchFamily="34" charset="-122"/>
@@ -3408,7 +3408,7 @@
             <a:r>
               <a:rPr lang="en-US" sz="4400" b="1" dirty="0">
                 <a:solidFill>
-                  <a:srgbClr val="F1EFEA"/>
+                  <a:srgbClr val="F3F2ED"/>
                 </a:solidFill>
                 <a:latin typeface="Arial" pitchFamily="34" charset="0"/>
                 <a:ea typeface="Arial" pitchFamily="34" charset="-122"/>
@@ -3451,7 +3451,7 @@
             <a:r>
               <a:rPr lang="en-US" sz="2400" dirty="0">
                 <a:solidFill>
-                  <a:srgbClr val="F1EFEA"/>
+                  <a:srgbClr val="F3F2ED"/>
                 </a:solidFill>
                 <a:latin typeface="Arial" pitchFamily="34" charset="0"/>
                 <a:ea typeface="Arial" pitchFamily="34" charset="-122"/>
@@ -3472,7 +3472,7 @@
             <a:r>
               <a:rPr lang="en-US" sz="2400" dirty="0">
                 <a:solidFill>
-                  <a:srgbClr val="F1EFEA"/>
+                  <a:srgbClr val="F3F2ED"/>
                 </a:solidFill>
                 <a:latin typeface="Arial" pitchFamily="34" charset="0"/>
                 <a:ea typeface="Arial" pitchFamily="34" charset="-122"/>
@@ -3493,7 +3493,7 @@
             <a:r>
               <a:rPr lang="en-US" sz="2400" dirty="0">
                 <a:solidFill>
-                  <a:srgbClr val="F1EFEA"/>
+                  <a:srgbClr val="F3F2ED"/>
                 </a:solidFill>
                 <a:latin typeface="Arial" pitchFamily="34" charset="0"/>
                 <a:ea typeface="Arial" pitchFamily="34" charset="-122"/>
@@ -3532,7 +3532,7 @@
             <a:r>
               <a:rPr lang="en-US" sz="1000" dirty="0">
                 <a:solidFill>
-                  <a:srgbClr val="F1EFEA"/>
+                  <a:srgbClr val="F3F2ED"/>
                 </a:solidFill>
                 <a:latin typeface="Courier New" pitchFamily="34" charset="0"/>
                 <a:ea typeface="Courier New" pitchFamily="34" charset="-122"/>
@@ -3571,11 +3571,11 @@
             <a:r>
               <a:rPr lang="en-US" sz="1100" dirty="0">
                 <a:solidFill>
-                  <a:srgbClr val="E3A98C"/>
-                </a:solidFill>
-                <a:latin typeface="Georgia" pitchFamily="34" charset="0"/>
-                <a:ea typeface="Georgia" pitchFamily="34" charset="-122"/>
-                <a:cs typeface="Georgia" pitchFamily="34" charset="-120"/>
+                  <a:srgbClr val="F3F2ED"/>
+                </a:solidFill>
+                <a:latin typeface="Arial" pitchFamily="34" charset="0"/>
+                <a:ea typeface="Arial" pitchFamily="34" charset="-122"/>
+                <a:cs typeface="Arial" pitchFamily="34" charset="-120"/>
               </a:rPr>
               <a:t>Fieldwork</a:t>
             </a:r>
@@ -3597,7 +3597,7 @@
     <p:bg>
       <p:bgPr>
         <a:solidFill>
-          <a:srgbClr val="F1EFEA"/>
+          <a:srgbClr val="F3F2ED"/>
         </a:solidFill>
       </p:bgPr>
     </p:bg>
@@ -3642,7 +3642,7 @@
             <a:r>
               <a:rPr lang="en-US" sz="1000" spc="200" kern="0" dirty="0">
                 <a:solidFill>
-                  <a:srgbClr val="A8512F"/>
+                  <a:srgbClr val="2340FF"/>
                 </a:solidFill>
                 <a:latin typeface="Courier New" pitchFamily="34" charset="0"/>
                 <a:ea typeface="Courier New" pitchFamily="34" charset="-122"/>
@@ -3681,7 +3681,7 @@
             <a:r>
               <a:rPr lang="en-US" sz="4400" b="1" dirty="0">
                 <a:solidFill>
-                  <a:srgbClr val="262422"/>
+                  <a:srgbClr val="121212"/>
                 </a:solidFill>
                 <a:latin typeface="Arial" pitchFamily="34" charset="0"/>
                 <a:ea typeface="Arial" pitchFamily="34" charset="-122"/>
@@ -3724,7 +3724,7 @@
             <a:r>
               <a:rPr lang="en-US" sz="2400" dirty="0">
                 <a:solidFill>
-                  <a:srgbClr val="262422"/>
+                  <a:srgbClr val="121212"/>
                 </a:solidFill>
                 <a:latin typeface="Arial" pitchFamily="34" charset="0"/>
                 <a:ea typeface="Arial" pitchFamily="34" charset="-122"/>
@@ -3745,7 +3745,7 @@
             <a:r>
               <a:rPr lang="en-US" sz="2400" dirty="0">
                 <a:solidFill>
-                  <a:srgbClr val="262422"/>
+                  <a:srgbClr val="121212"/>
                 </a:solidFill>
                 <a:latin typeface="Arial" pitchFamily="34" charset="0"/>
                 <a:ea typeface="Arial" pitchFamily="34" charset="-122"/>
@@ -3766,7 +3766,7 @@
             <a:r>
               <a:rPr lang="en-US" sz="2400" dirty="0">
                 <a:solidFill>
-                  <a:srgbClr val="262422"/>
+                  <a:srgbClr val="121212"/>
                 </a:solidFill>
                 <a:latin typeface="Arial" pitchFamily="34" charset="0"/>
                 <a:ea typeface="Arial" pitchFamily="34" charset="-122"/>
@@ -3787,7 +3787,7 @@
             <a:r>
               <a:rPr lang="en-US" sz="2400" dirty="0">
                 <a:solidFill>
-                  <a:srgbClr val="262422"/>
+                  <a:srgbClr val="121212"/>
                 </a:solidFill>
                 <a:latin typeface="Arial" pitchFamily="34" charset="0"/>
                 <a:ea typeface="Arial" pitchFamily="34" charset="-122"/>
@@ -3826,7 +3826,7 @@
             <a:r>
               <a:rPr lang="en-US" sz="1000" dirty="0">
                 <a:solidFill>
-                  <a:srgbClr val="262422"/>
+                  <a:srgbClr val="121212"/>
                 </a:solidFill>
                 <a:latin typeface="Courier New" pitchFamily="34" charset="0"/>
                 <a:ea typeface="Courier New" pitchFamily="34" charset="-122"/>
@@ -3865,11 +3865,11 @@
             <a:r>
               <a:rPr lang="en-US" sz="1100" dirty="0">
                 <a:solidFill>
-                  <a:srgbClr val="A8512F"/>
-                </a:solidFill>
-                <a:latin typeface="Georgia" pitchFamily="34" charset="0"/>
-                <a:ea typeface="Georgia" pitchFamily="34" charset="-122"/>
-                <a:cs typeface="Georgia" pitchFamily="34" charset="-120"/>
+                  <a:srgbClr val="2340FF"/>
+                </a:solidFill>
+                <a:latin typeface="Arial" pitchFamily="34" charset="0"/>
+                <a:ea typeface="Arial" pitchFamily="34" charset="-122"/>
+                <a:cs typeface="Arial" pitchFamily="34" charset="-120"/>
               </a:rPr>
               <a:t>Fieldwork</a:t>
             </a:r>
@@ -3891,7 +3891,7 @@
     <p:bg>
       <p:bgPr>
         <a:solidFill>
-          <a:srgbClr val="F1EFEA"/>
+          <a:srgbClr val="F3F2ED"/>
         </a:solidFill>
       </p:bgPr>
     </p:bg>
@@ -3936,7 +3936,7 @@
             <a:r>
               <a:rPr lang="en-US" sz="1000" spc="200" kern="0" dirty="0">
                 <a:solidFill>
-                  <a:srgbClr val="A8512F"/>
+                  <a:srgbClr val="2340FF"/>
                 </a:solidFill>
                 <a:latin typeface="Courier New" pitchFamily="34" charset="0"/>
                 <a:ea typeface="Courier New" pitchFamily="34" charset="-122"/>
@@ -3975,7 +3975,7 @@
             <a:r>
               <a:rPr lang="en-US" sz="4400" b="1" dirty="0">
                 <a:solidFill>
-                  <a:srgbClr val="262422"/>
+                  <a:srgbClr val="121212"/>
                 </a:solidFill>
                 <a:latin typeface="Arial" pitchFamily="34" charset="0"/>
                 <a:ea typeface="Arial" pitchFamily="34" charset="-122"/>
@@ -4018,7 +4018,7 @@
             <a:r>
               <a:rPr lang="en-US" sz="2400" dirty="0">
                 <a:solidFill>
-                  <a:srgbClr val="262422"/>
+                  <a:srgbClr val="121212"/>
                 </a:solidFill>
                 <a:latin typeface="Arial" pitchFamily="34" charset="0"/>
                 <a:ea typeface="Arial" pitchFamily="34" charset="-122"/>
@@ -4039,7 +4039,7 @@
             <a:r>
               <a:rPr lang="en-US" sz="2400" dirty="0">
                 <a:solidFill>
-                  <a:srgbClr val="262422"/>
+                  <a:srgbClr val="121212"/>
                 </a:solidFill>
                 <a:latin typeface="Arial" pitchFamily="34" charset="0"/>
                 <a:ea typeface="Arial" pitchFamily="34" charset="-122"/>
@@ -4060,7 +4060,7 @@
             <a:r>
               <a:rPr lang="en-US" sz="2400" dirty="0">
                 <a:solidFill>
-                  <a:srgbClr val="262422"/>
+                  <a:srgbClr val="121212"/>
                 </a:solidFill>
                 <a:latin typeface="Arial" pitchFamily="34" charset="0"/>
                 <a:ea typeface="Arial" pitchFamily="34" charset="-122"/>
@@ -4081,7 +4081,7 @@
             <a:r>
               <a:rPr lang="en-US" sz="2400" dirty="0">
                 <a:solidFill>
-                  <a:srgbClr val="262422"/>
+                  <a:srgbClr val="121212"/>
                 </a:solidFill>
                 <a:latin typeface="Arial" pitchFamily="34" charset="0"/>
                 <a:ea typeface="Arial" pitchFamily="34" charset="-122"/>
@@ -4120,11 +4120,11 @@
             <a:r>
               <a:rPr lang="en-US" sz="1100" dirty="0">
                 <a:solidFill>
-                  <a:srgbClr val="A8512F"/>
-                </a:solidFill>
-                <a:latin typeface="Georgia" pitchFamily="34" charset="0"/>
-                <a:ea typeface="Georgia" pitchFamily="34" charset="-122"/>
-                <a:cs typeface="Georgia" pitchFamily="34" charset="-120"/>
+                  <a:srgbClr val="2340FF"/>
+                </a:solidFill>
+                <a:latin typeface="Arial" pitchFamily="34" charset="0"/>
+                <a:ea typeface="Arial" pitchFamily="34" charset="-122"/>
+                <a:cs typeface="Arial" pitchFamily="34" charset="-120"/>
               </a:rPr>
               <a:t>Fieldwork</a:t>
             </a:r>
@@ -4146,7 +4146,7 @@
     <p:bg>
       <p:bgPr>
         <a:solidFill>
-          <a:srgbClr val="F1EFEA"/>
+          <a:srgbClr val="F3F2ED"/>
         </a:solidFill>
       </p:bgPr>
     </p:bg>
@@ -4191,7 +4191,7 @@
             <a:r>
               <a:rPr lang="en-US" sz="1000" spc="200" kern="0" dirty="0">
                 <a:solidFill>
-                  <a:srgbClr val="A8512F"/>
+                  <a:srgbClr val="2340FF"/>
                 </a:solidFill>
                 <a:latin typeface="Courier New" pitchFamily="34" charset="0"/>
                 <a:ea typeface="Courier New" pitchFamily="34" charset="-122"/>
@@ -4230,7 +4230,7 @@
             <a:r>
               <a:rPr lang="en-US" sz="4400" b="1" dirty="0">
                 <a:solidFill>
-                  <a:srgbClr val="262422"/>
+                  <a:srgbClr val="121212"/>
                 </a:solidFill>
                 <a:latin typeface="Arial" pitchFamily="34" charset="0"/>
                 <a:ea typeface="Arial" pitchFamily="34" charset="-122"/>
@@ -4273,7 +4273,7 @@
             <a:r>
               <a:rPr lang="en-US" sz="2400" dirty="0">
                 <a:solidFill>
-                  <a:srgbClr val="262422"/>
+                  <a:srgbClr val="121212"/>
                 </a:solidFill>
                 <a:latin typeface="Arial" pitchFamily="34" charset="0"/>
                 <a:ea typeface="Arial" pitchFamily="34" charset="-122"/>
@@ -4294,7 +4294,7 @@
             <a:r>
               <a:rPr lang="en-US" sz="2400" dirty="0">
                 <a:solidFill>
-                  <a:srgbClr val="262422"/>
+                  <a:srgbClr val="121212"/>
                 </a:solidFill>
                 <a:latin typeface="Arial" pitchFamily="34" charset="0"/>
                 <a:ea typeface="Arial" pitchFamily="34" charset="-122"/>
@@ -4315,7 +4315,7 @@
             <a:r>
               <a:rPr lang="en-US" sz="2400" dirty="0">
                 <a:solidFill>
-                  <a:srgbClr val="262422"/>
+                  <a:srgbClr val="121212"/>
                 </a:solidFill>
                 <a:latin typeface="Arial" pitchFamily="34" charset="0"/>
                 <a:ea typeface="Arial" pitchFamily="34" charset="-122"/>
@@ -4336,7 +4336,7 @@
             <a:r>
               <a:rPr lang="en-US" sz="2400" dirty="0">
                 <a:solidFill>
-                  <a:srgbClr val="262422"/>
+                  <a:srgbClr val="121212"/>
                 </a:solidFill>
                 <a:latin typeface="Arial" pitchFamily="34" charset="0"/>
                 <a:ea typeface="Arial" pitchFamily="34" charset="-122"/>
@@ -4375,11 +4375,11 @@
             <a:r>
               <a:rPr lang="en-US" sz="1100" dirty="0">
                 <a:solidFill>
-                  <a:srgbClr val="A8512F"/>
-                </a:solidFill>
-                <a:latin typeface="Georgia" pitchFamily="34" charset="0"/>
-                <a:ea typeface="Georgia" pitchFamily="34" charset="-122"/>
-                <a:cs typeface="Georgia" pitchFamily="34" charset="-120"/>
+                  <a:srgbClr val="2340FF"/>
+                </a:solidFill>
+                <a:latin typeface="Arial" pitchFamily="34" charset="0"/>
+                <a:ea typeface="Arial" pitchFamily="34" charset="-122"/>
+                <a:cs typeface="Arial" pitchFamily="34" charset="-120"/>
               </a:rPr>
               <a:t>Fieldwork</a:t>
             </a:r>
@@ -4401,7 +4401,7 @@
     <p:bg>
       <p:bgPr>
         <a:solidFill>
-          <a:srgbClr val="25306E"/>
+          <a:srgbClr val="2340FF"/>
         </a:solidFill>
       </p:bgPr>
     </p:bg>
@@ -4446,7 +4446,7 @@
             <a:r>
               <a:rPr lang="en-US" sz="1000" spc="200" kern="0" dirty="0">
                 <a:solidFill>
-                  <a:srgbClr val="E3A98C"/>
+                  <a:srgbClr val="F3F2ED"/>
                 </a:solidFill>
                 <a:latin typeface="Courier New" pitchFamily="34" charset="0"/>
                 <a:ea typeface="Courier New" pitchFamily="34" charset="-122"/>
@@ -4485,7 +4485,7 @@
             <a:r>
               <a:rPr lang="en-US" sz="4400" b="1" dirty="0">
                 <a:solidFill>
-                  <a:srgbClr val="F1EFEA"/>
+                  <a:srgbClr val="F3F2ED"/>
                 </a:solidFill>
                 <a:latin typeface="Arial" pitchFamily="34" charset="0"/>
                 <a:ea typeface="Arial" pitchFamily="34" charset="-122"/>
@@ -4528,7 +4528,7 @@
             <a:r>
               <a:rPr lang="en-US" sz="2400" dirty="0">
                 <a:solidFill>
-                  <a:srgbClr val="F1EFEA"/>
+                  <a:srgbClr val="F3F2ED"/>
                 </a:solidFill>
                 <a:latin typeface="Arial" pitchFamily="34" charset="0"/>
                 <a:ea typeface="Arial" pitchFamily="34" charset="-122"/>
@@ -4567,11 +4567,11 @@
             <a:r>
               <a:rPr lang="en-US" sz="1100" dirty="0">
                 <a:solidFill>
-                  <a:srgbClr val="E3A98C"/>
-                </a:solidFill>
-                <a:latin typeface="Georgia" pitchFamily="34" charset="0"/>
-                <a:ea typeface="Georgia" pitchFamily="34" charset="-122"/>
-                <a:cs typeface="Georgia" pitchFamily="34" charset="-120"/>
+                  <a:srgbClr val="F3F2ED"/>
+                </a:solidFill>
+                <a:latin typeface="Arial" pitchFamily="34" charset="0"/>
+                <a:ea typeface="Arial" pitchFamily="34" charset="-122"/>
+                <a:cs typeface="Arial" pitchFamily="34" charset="-120"/>
               </a:rPr>
               <a:t>Fieldwork</a:t>
             </a:r>
@@ -4593,7 +4593,7 @@
     <p:bg>
       <p:bgPr>
         <a:solidFill>
-          <a:srgbClr val="F1EFEA"/>
+          <a:srgbClr val="F3F2ED"/>
         </a:solidFill>
       </p:bgPr>
     </p:bg>
@@ -4638,7 +4638,7 @@
             <a:r>
               <a:rPr lang="en-US" sz="1000" spc="200" kern="0" dirty="0">
                 <a:solidFill>
-                  <a:srgbClr val="A8512F"/>
+                  <a:srgbClr val="2340FF"/>
                 </a:solidFill>
                 <a:latin typeface="Courier New" pitchFamily="34" charset="0"/>
                 <a:ea typeface="Courier New" pitchFamily="34" charset="-122"/>
@@ -4677,7 +4677,7 @@
             <a:r>
               <a:rPr lang="en-US" sz="4400" b="1" dirty="0">
                 <a:solidFill>
-                  <a:srgbClr val="262422"/>
+                  <a:srgbClr val="121212"/>
                 </a:solidFill>
                 <a:latin typeface="Arial" pitchFamily="34" charset="0"/>
                 <a:ea typeface="Arial" pitchFamily="34" charset="-122"/>
@@ -4720,7 +4720,7 @@
             <a:r>
               <a:rPr lang="en-US" sz="2400" dirty="0">
                 <a:solidFill>
-                  <a:srgbClr val="262422"/>
+                  <a:srgbClr val="121212"/>
                 </a:solidFill>
                 <a:latin typeface="Arial" pitchFamily="34" charset="0"/>
                 <a:ea typeface="Arial" pitchFamily="34" charset="-122"/>
@@ -4741,7 +4741,7 @@
             <a:r>
               <a:rPr lang="en-US" sz="2400" dirty="0">
                 <a:solidFill>
-                  <a:srgbClr val="262422"/>
+                  <a:srgbClr val="121212"/>
                 </a:solidFill>
                 <a:latin typeface="Arial" pitchFamily="34" charset="0"/>
                 <a:ea typeface="Arial" pitchFamily="34" charset="-122"/>
@@ -4762,7 +4762,7 @@
             <a:r>
               <a:rPr lang="en-US" sz="2400" dirty="0">
                 <a:solidFill>
-                  <a:srgbClr val="262422"/>
+                  <a:srgbClr val="121212"/>
                 </a:solidFill>
                 <a:latin typeface="Arial" pitchFamily="34" charset="0"/>
                 <a:ea typeface="Arial" pitchFamily="34" charset="-122"/>
@@ -4783,7 +4783,7 @@
             <a:r>
               <a:rPr lang="en-US" sz="2400" dirty="0">
                 <a:solidFill>
-                  <a:srgbClr val="262422"/>
+                  <a:srgbClr val="121212"/>
                 </a:solidFill>
                 <a:latin typeface="Arial" pitchFamily="34" charset="0"/>
                 <a:ea typeface="Arial" pitchFamily="34" charset="-122"/>
@@ -4804,7 +4804,7 @@
             <a:r>
               <a:rPr lang="en-US" sz="2400" dirty="0">
                 <a:solidFill>
-                  <a:srgbClr val="262422"/>
+                  <a:srgbClr val="121212"/>
                 </a:solidFill>
                 <a:latin typeface="Arial" pitchFamily="34" charset="0"/>
                 <a:ea typeface="Arial" pitchFamily="34" charset="-122"/>
@@ -4825,7 +4825,7 @@
             <a:r>
               <a:rPr lang="en-US" sz="2400" dirty="0">
                 <a:solidFill>
-                  <a:srgbClr val="262422"/>
+                  <a:srgbClr val="121212"/>
                 </a:solidFill>
                 <a:latin typeface="Arial" pitchFamily="34" charset="0"/>
                 <a:ea typeface="Arial" pitchFamily="34" charset="-122"/>
@@ -4846,7 +4846,7 @@
             <a:r>
               <a:rPr lang="en-US" sz="2400" dirty="0">
                 <a:solidFill>
-                  <a:srgbClr val="262422"/>
+                  <a:srgbClr val="121212"/>
                 </a:solidFill>
                 <a:latin typeface="Arial" pitchFamily="34" charset="0"/>
                 <a:ea typeface="Arial" pitchFamily="34" charset="-122"/>
@@ -4885,7 +4885,7 @@
             <a:r>
               <a:rPr lang="en-US" sz="1000" dirty="0">
                 <a:solidFill>
-                  <a:srgbClr val="262422"/>
+                  <a:srgbClr val="121212"/>
                 </a:solidFill>
                 <a:latin typeface="Courier New" pitchFamily="34" charset="0"/>
                 <a:ea typeface="Courier New" pitchFamily="34" charset="-122"/>
@@ -4924,11 +4924,11 @@
             <a:r>
               <a:rPr lang="en-US" sz="1100" dirty="0">
                 <a:solidFill>
-                  <a:srgbClr val="A8512F"/>
-                </a:solidFill>
-                <a:latin typeface="Georgia" pitchFamily="34" charset="0"/>
-                <a:ea typeface="Georgia" pitchFamily="34" charset="-122"/>
-                <a:cs typeface="Georgia" pitchFamily="34" charset="-120"/>
+                  <a:srgbClr val="2340FF"/>
+                </a:solidFill>
+                <a:latin typeface="Arial" pitchFamily="34" charset="0"/>
+                <a:ea typeface="Arial" pitchFamily="34" charset="-122"/>
+                <a:cs typeface="Arial" pitchFamily="34" charset="-120"/>
               </a:rPr>
               <a:t>Fieldwork</a:t>
             </a:r>
@@ -4950,7 +4950,7 @@
     <p:bg>
       <p:bgPr>
         <a:solidFill>
-          <a:srgbClr val="F1EFEA"/>
+          <a:srgbClr val="F3F2ED"/>
         </a:solidFill>
       </p:bgPr>
     </p:bg>
@@ -4995,7 +4995,7 @@
             <a:r>
               <a:rPr lang="en-US" sz="1000" spc="200" kern="0" dirty="0">
                 <a:solidFill>
-                  <a:srgbClr val="A8512F"/>
+                  <a:srgbClr val="2340FF"/>
                 </a:solidFill>
                 <a:latin typeface="Courier New" pitchFamily="34" charset="0"/>
                 <a:ea typeface="Courier New" pitchFamily="34" charset="-122"/>
@@ -5034,7 +5034,7 @@
             <a:r>
               <a:rPr lang="en-US" sz="4400" b="1" dirty="0">
                 <a:solidFill>
-                  <a:srgbClr val="262422"/>
+                  <a:srgbClr val="121212"/>
                 </a:solidFill>
                 <a:latin typeface="Arial" pitchFamily="34" charset="0"/>
                 <a:ea typeface="Arial" pitchFamily="34" charset="-122"/>
@@ -5077,7 +5077,7 @@
             <a:r>
               <a:rPr lang="en-US" sz="2400" dirty="0">
                 <a:solidFill>
-                  <a:srgbClr val="262422"/>
+                  <a:srgbClr val="121212"/>
                 </a:solidFill>
                 <a:latin typeface="Arial" pitchFamily="34" charset="0"/>
                 <a:ea typeface="Arial" pitchFamily="34" charset="-122"/>
@@ -5098,7 +5098,7 @@
             <a:r>
               <a:rPr lang="en-US" sz="2400" dirty="0">
                 <a:solidFill>
-                  <a:srgbClr val="262422"/>
+                  <a:srgbClr val="121212"/>
                 </a:solidFill>
                 <a:latin typeface="Arial" pitchFamily="34" charset="0"/>
                 <a:ea typeface="Arial" pitchFamily="34" charset="-122"/>
@@ -5119,7 +5119,7 @@
             <a:r>
               <a:rPr lang="en-US" sz="2400" dirty="0">
                 <a:solidFill>
-                  <a:srgbClr val="262422"/>
+                  <a:srgbClr val="121212"/>
                 </a:solidFill>
                 <a:latin typeface="Arial" pitchFamily="34" charset="0"/>
                 <a:ea typeface="Arial" pitchFamily="34" charset="-122"/>
@@ -5140,7 +5140,7 @@
             <a:r>
               <a:rPr lang="en-US" sz="2400" dirty="0">
                 <a:solidFill>
-                  <a:srgbClr val="262422"/>
+                  <a:srgbClr val="121212"/>
                 </a:solidFill>
                 <a:latin typeface="Arial" pitchFamily="34" charset="0"/>
                 <a:ea typeface="Arial" pitchFamily="34" charset="-122"/>
@@ -5179,7 +5179,7 @@
             <a:r>
               <a:rPr lang="en-US" sz="1000" dirty="0">
                 <a:solidFill>
-                  <a:srgbClr val="262422"/>
+                  <a:srgbClr val="121212"/>
                 </a:solidFill>
                 <a:latin typeface="Courier New" pitchFamily="34" charset="0"/>
                 <a:ea typeface="Courier New" pitchFamily="34" charset="-122"/>
@@ -5218,11 +5218,11 @@
             <a:r>
               <a:rPr lang="en-US" sz="1100" dirty="0">
                 <a:solidFill>
-                  <a:srgbClr val="A8512F"/>
-                </a:solidFill>
-                <a:latin typeface="Georgia" pitchFamily="34" charset="0"/>
-                <a:ea typeface="Georgia" pitchFamily="34" charset="-122"/>
-                <a:cs typeface="Georgia" pitchFamily="34" charset="-120"/>
+                  <a:srgbClr val="2340FF"/>
+                </a:solidFill>
+                <a:latin typeface="Arial" pitchFamily="34" charset="0"/>
+                <a:ea typeface="Arial" pitchFamily="34" charset="-122"/>
+                <a:cs typeface="Arial" pitchFamily="34" charset="-120"/>
               </a:rPr>
               <a:t>Fieldwork</a:t>
             </a:r>
@@ -5244,7 +5244,7 @@
     <p:bg>
       <p:bgPr>
         <a:solidFill>
-          <a:srgbClr val="262422"/>
+          <a:srgbClr val="121212"/>
         </a:solidFill>
       </p:bgPr>
     </p:bg>
@@ -5289,7 +5289,7 @@
             <a:r>
               <a:rPr lang="en-US" sz="1000" spc="200" kern="0" dirty="0">
                 <a:solidFill>
-                  <a:srgbClr val="E3A98C"/>
+                  <a:srgbClr val="7C8FFF"/>
                 </a:solidFill>
                 <a:latin typeface="Courier New" pitchFamily="34" charset="0"/>
                 <a:ea typeface="Courier New" pitchFamily="34" charset="-122"/>
@@ -5328,7 +5328,7 @@
             <a:r>
               <a:rPr lang="en-US" sz="4400" b="1" dirty="0">
                 <a:solidFill>
-                  <a:srgbClr val="F1EFEA"/>
+                  <a:srgbClr val="F3F2ED"/>
                 </a:solidFill>
                 <a:latin typeface="Arial" pitchFamily="34" charset="0"/>
                 <a:ea typeface="Arial" pitchFamily="34" charset="-122"/>
@@ -5371,7 +5371,7 @@
             <a:r>
               <a:rPr lang="en-US" sz="2400" dirty="0">
                 <a:solidFill>
-                  <a:srgbClr val="F1EFEA"/>
+                  <a:srgbClr val="F3F2ED"/>
                 </a:solidFill>
                 <a:latin typeface="Arial" pitchFamily="34" charset="0"/>
                 <a:ea typeface="Arial" pitchFamily="34" charset="-122"/>
@@ -5392,7 +5392,7 @@
             <a:r>
               <a:rPr lang="en-US" sz="2400" dirty="0">
                 <a:solidFill>
-                  <a:srgbClr val="F1EFEA"/>
+                  <a:srgbClr val="F3F2ED"/>
                 </a:solidFill>
                 <a:latin typeface="Arial" pitchFamily="34" charset="0"/>
                 <a:ea typeface="Arial" pitchFamily="34" charset="-122"/>
@@ -5413,7 +5413,7 @@
             <a:r>
               <a:rPr lang="en-US" sz="2400" dirty="0">
                 <a:solidFill>
-                  <a:srgbClr val="F1EFEA"/>
+                  <a:srgbClr val="F3F2ED"/>
                 </a:solidFill>
                 <a:latin typeface="Arial" pitchFamily="34" charset="0"/>
                 <a:ea typeface="Arial" pitchFamily="34" charset="-122"/>
@@ -5434,7 +5434,7 @@
             <a:r>
               <a:rPr lang="en-US" sz="2400" dirty="0">
                 <a:solidFill>
-                  <a:srgbClr val="F1EFEA"/>
+                  <a:srgbClr val="F3F2ED"/>
                 </a:solidFill>
                 <a:latin typeface="Arial" pitchFamily="34" charset="0"/>
                 <a:ea typeface="Arial" pitchFamily="34" charset="-122"/>
@@ -5473,11 +5473,11 @@
             <a:r>
               <a:rPr lang="en-US" sz="1100" dirty="0">
                 <a:solidFill>
-                  <a:srgbClr val="E3A98C"/>
-                </a:solidFill>
-                <a:latin typeface="Georgia" pitchFamily="34" charset="0"/>
-                <a:ea typeface="Georgia" pitchFamily="34" charset="-122"/>
-                <a:cs typeface="Georgia" pitchFamily="34" charset="-120"/>
+                  <a:srgbClr val="7C8FFF"/>
+                </a:solidFill>
+                <a:latin typeface="Arial" pitchFamily="34" charset="0"/>
+                <a:ea typeface="Arial" pitchFamily="34" charset="-122"/>
+                <a:cs typeface="Arial" pitchFamily="34" charset="-120"/>
               </a:rPr>
               <a:t>Fieldwork</a:t>
             </a:r>
@@ -5499,7 +5499,7 @@
     <p:bg>
       <p:bgPr>
         <a:solidFill>
-          <a:srgbClr val="F1EFEA"/>
+          <a:srgbClr val="F3F2ED"/>
         </a:solidFill>
       </p:bgPr>
     </p:bg>
@@ -5544,7 +5544,7 @@
             <a:r>
               <a:rPr lang="en-US" sz="1000" spc="200" kern="0" dirty="0">
                 <a:solidFill>
-                  <a:srgbClr val="A8512F"/>
+                  <a:srgbClr val="2340FF"/>
                 </a:solidFill>
                 <a:latin typeface="Courier New" pitchFamily="34" charset="0"/>
                 <a:ea typeface="Courier New" pitchFamily="34" charset="-122"/>
@@ -5583,7 +5583,7 @@
             <a:r>
               <a:rPr lang="en-US" sz="4400" b="1" dirty="0">
                 <a:solidFill>
-                  <a:srgbClr val="262422"/>
+                  <a:srgbClr val="121212"/>
                 </a:solidFill>
                 <a:latin typeface="Arial" pitchFamily="34" charset="0"/>
                 <a:ea typeface="Arial" pitchFamily="34" charset="-122"/>
@@ -5626,7 +5626,7 @@
             <a:r>
               <a:rPr lang="en-US" sz="2400" dirty="0">
                 <a:solidFill>
-                  <a:srgbClr val="262422"/>
+                  <a:srgbClr val="121212"/>
                 </a:solidFill>
                 <a:latin typeface="Arial" pitchFamily="34" charset="0"/>
                 <a:ea typeface="Arial" pitchFamily="34" charset="-122"/>
@@ -5647,7 +5647,7 @@
             <a:r>
               <a:rPr lang="en-US" sz="2400" dirty="0">
                 <a:solidFill>
-                  <a:srgbClr val="262422"/>
+                  <a:srgbClr val="121212"/>
                 </a:solidFill>
                 <a:latin typeface="Arial" pitchFamily="34" charset="0"/>
                 <a:ea typeface="Arial" pitchFamily="34" charset="-122"/>
@@ -5668,7 +5668,7 @@
             <a:r>
               <a:rPr lang="en-US" sz="2400" dirty="0">
                 <a:solidFill>
-                  <a:srgbClr val="262422"/>
+                  <a:srgbClr val="121212"/>
                 </a:solidFill>
                 <a:latin typeface="Arial" pitchFamily="34" charset="0"/>
                 <a:ea typeface="Arial" pitchFamily="34" charset="-122"/>
@@ -5707,7 +5707,7 @@
             <a:r>
               <a:rPr lang="en-US" sz="1000" dirty="0">
                 <a:solidFill>
-                  <a:srgbClr val="262422"/>
+                  <a:srgbClr val="121212"/>
                 </a:solidFill>
                 <a:latin typeface="Courier New" pitchFamily="34" charset="0"/>
                 <a:ea typeface="Courier New" pitchFamily="34" charset="-122"/>
@@ -5746,11 +5746,11 @@
             <a:r>
               <a:rPr lang="en-US" sz="1100" dirty="0">
                 <a:solidFill>
-                  <a:srgbClr val="A8512F"/>
-                </a:solidFill>
-                <a:latin typeface="Georgia" pitchFamily="34" charset="0"/>
-                <a:ea typeface="Georgia" pitchFamily="34" charset="-122"/>
-                <a:cs typeface="Georgia" pitchFamily="34" charset="-120"/>
+                  <a:srgbClr val="2340FF"/>
+                </a:solidFill>
+                <a:latin typeface="Arial" pitchFamily="34" charset="0"/>
+                <a:ea typeface="Arial" pitchFamily="34" charset="-122"/>
+                <a:cs typeface="Arial" pitchFamily="34" charset="-120"/>
               </a:rPr>
               <a:t>Fieldwork</a:t>
             </a:r>

</xml_diff>